<commit_message>
Add Mermaid diagram pipeline and uv/npm tooling for A3 decks.
Render assets/diagrams/a3/*.mmd with mmdc (Pillow fallback), embed on all A3
slides, and lock Python deps via uv plus local mermaid-cli via npm.

Co-authored-by: Cursor <cursoragent@cursor.com>
</commit_message>
<xml_diff>
--- a/dt100/manager-arch-vision-a3.pptx
+++ b/dt100/manager-arch-vision-a3.pptx
@@ -2354,7 +2354,7 @@
           <a:p/>
           <a:p>
             <a:r>
-              <a:t>Instill closed-loop SW-HW validation (use-case → models → tape-out) — tactical verbal only; see dt100/manager-arch-vision-a3-unpublished.md.</a:t>
+              <a:t>Instill closed-loop SW-HW validation (use-case → models → tape-out) — tactical verbal only; see dt100/README.md Private prep.</a:t>
             </a:r>
           </a:p>
           <a:p/>
@@ -4948,6 +4948,30 @@
           </a:p>
         </p:txBody>
       </p:sp>
+      <p:pic>
+        <p:nvPicPr>
+          <p:cNvPr id="38" name="Picture 37" descr="slide00-cover.png"/>
+          <p:cNvPicPr>
+            <a:picLocks noChangeAspect="1"/>
+          </p:cNvPicPr>
+          <p:nvPr/>
+        </p:nvPicPr>
+        <p:blipFill>
+          <a:blip r:embed="rId3"/>
+          <a:stretch>
+            <a:fillRect/>
+          </a:stretch>
+        </p:blipFill>
+        <p:spPr>
+          <a:xfrm>
+            <a:off x="502920" y="1874519"/>
+            <a:ext cx="5303520" cy="675516"/>
+          </a:xfrm>
+          <a:prstGeom prst="rect">
+            <a:avLst/>
+          </a:prstGeom>
+        </p:spPr>
+      </p:pic>
     </p:spTree>
   </p:cSld>
   <p:clrMapOvr>
@@ -5390,52 +5414,32 @@
           <a:p>
             <a:pPr/>
           </a:p>
-          <a:p>
-            <a:pPr/>
-            <a:r>
-              <a:rPr>
-                <a:solidFill>
-                  <a:srgbClr val="333333"/>
-                </a:solidFill>
-              </a:rPr>
-              <a:t>done and validated · product · management plane · AV</a:t>
-            </a:r>
-          </a:p>
-          <a:p>
-            <a:pPr/>
-            <a:r>
-              <a:rPr>
-                <a:solidFill>
-                  <a:srgbClr val="333333"/>
-                </a:solidFill>
-              </a:rPr>
-              <a:t>SDK/SAI · C-model → emulation → silicon</a:t>
-            </a:r>
-          </a:p>
-          <a:p>
-            <a:pPr/>
-            <a:r>
-              <a:rPr>
-                <a:solidFill>
-                  <a:srgbClr val="333333"/>
-                </a:solidFill>
-              </a:rPr>
-              <a:t>CSB buffer carving — not datapath architecture</a:t>
-            </a:r>
-          </a:p>
-          <a:p>
-            <a:pPr/>
-            <a:r>
-              <a:rPr>
-                <a:solidFill>
-                  <a:srgbClr val="333333"/>
-                </a:solidFill>
-              </a:rPr>
-              <a:t>Align today</a:t>
-            </a:r>
-          </a:p>
         </p:txBody>
       </p:sp>
+      <p:pic>
+        <p:nvPicPr>
+          <p:cNvPr id="59" name="Picture 58" descr="slide01-scope.png"/>
+          <p:cNvPicPr>
+            <a:picLocks noChangeAspect="1"/>
+          </p:cNvPicPr>
+          <p:nvPr/>
+        </p:nvPicPr>
+        <p:blipFill>
+          <a:blip r:embed="rId3"/>
+          <a:stretch>
+            <a:fillRect/>
+          </a:stretch>
+        </p:blipFill>
+        <p:spPr>
+          <a:xfrm>
+            <a:off x="411480" y="1143000"/>
+            <a:ext cx="11155680" cy="2121284"/>
+          </a:xfrm>
+          <a:prstGeom prst="rect">
+            <a:avLst/>
+          </a:prstGeom>
+        </p:spPr>
+      </p:pic>
     </p:spTree>
   </p:cSld>
   <p:clrMapOvr>
@@ -5840,7 +5844,7 @@
           </a:bodyPr>
           <a:lstStyle/>
           <a:p>
-            <a:pPr marL="457200" marR="0" indent="-307975" algn="l" rtl="0">
+            <a:pPr marL="457200" marR="0" lvl="0" indent="-307975" algn="l" rtl="0">
               <a:lnSpc>
                 <a:spcPct val="115000"/>
               </a:lnSpc>
@@ -5857,14 +5861,6 @@
               <a:buFont typeface="Arial"/>
               <a:buChar char="●"/>
             </a:pPr>
-            <a:r>
-              <a:rPr>
-                <a:solidFill>
-                  <a:srgbClr val="333333"/>
-                </a:solidFill>
-              </a:rPr>
-              <a:t>QoSMAP · Queue · buffer carving</a:t>
-            </a:r>
             <a:endParaRPr sz="1250" b="0" i="0" u="none" strike="noStrike" cap="none">
               <a:solidFill>
                 <a:schemeClr val="dk1"/>
@@ -5875,30 +5871,32 @@
               <a:sym typeface="Arial"/>
             </a:endParaRPr>
           </a:p>
-          <a:p>
-            <a:pPr/>
-            <a:r>
-              <a:rPr>
-                <a:solidFill>
-                  <a:srgbClr val="333333"/>
-                </a:solidFill>
-              </a:rPr>
-              <a:t>Layer 2 / Layer 3 · ECMP — peer DRIs</a:t>
-            </a:r>
-          </a:p>
-          <a:p>
-            <a:pPr/>
-            <a:r>
-              <a:rPr>
-                <a:solidFill>
-                  <a:srgbClr val="333333"/>
-                </a:solidFill>
-              </a:rPr>
-              <a:t>Backup deck — logical pipeline walk</a:t>
-            </a:r>
-          </a:p>
         </p:txBody>
       </p:sp>
+      <p:pic>
+        <p:nvPicPr>
+          <p:cNvPr id="70" name="Picture 69" descr="slide02-validated.png"/>
+          <p:cNvPicPr>
+            <a:picLocks noChangeAspect="1"/>
+          </p:cNvPicPr>
+          <p:nvPr/>
+        </p:nvPicPr>
+        <p:blipFill>
+          <a:blip r:embed="rId3"/>
+          <a:stretch>
+            <a:fillRect/>
+          </a:stretch>
+        </p:blipFill>
+        <p:spPr>
+          <a:xfrm>
+            <a:off x="411480" y="1143000"/>
+            <a:ext cx="11155680" cy="3232156"/>
+          </a:xfrm>
+          <a:prstGeom prst="rect">
+            <a:avLst/>
+          </a:prstGeom>
+        </p:spPr>
+      </p:pic>
     </p:spTree>
   </p:cSld>
   <p:clrMapOvr>
@@ -6303,7 +6301,7 @@
           </a:bodyPr>
           <a:lstStyle/>
           <a:p>
-            <a:pPr marL="457200" marR="0" indent="-307975" algn="l" rtl="0">
+            <a:pPr marL="457200" marR="0" lvl="0" indent="-307975" algn="l" rtl="0">
               <a:lnSpc>
                 <a:spcPct val="115000"/>
               </a:lnSpc>
@@ -6320,14 +6318,6 @@
               <a:buFont typeface="Arial"/>
               <a:buChar char="●"/>
             </a:pPr>
-            <a:r>
-              <a:rPr>
-                <a:solidFill>
-                  <a:srgbClr val="333333"/>
-                </a:solidFill>
-              </a:rPr>
-              <a:t>Cx two-pager · validation gates (~two weeks)</a:t>
-            </a:r>
             <a:endParaRPr sz="1250" b="0" i="0" u="none" strike="noStrike" cap="none">
               <a:solidFill>
                 <a:schemeClr val="dk1"/>
@@ -6338,41 +6328,32 @@
               <a:sym typeface="Arial"/>
             </a:endParaRPr>
           </a:p>
-          <a:p>
-            <a:pPr/>
-            <a:r>
-              <a:rPr>
-                <a:solidFill>
-                  <a:srgbClr val="333333"/>
-                </a:solidFill>
-              </a:rPr>
-              <a:t>done and validated · before tape-out</a:t>
-            </a:r>
-          </a:p>
-          <a:p>
-            <a:pPr/>
-            <a:r>
-              <a:rPr>
-                <a:solidFill>
-                  <a:srgbClr val="333333"/>
-                </a:solidFill>
-              </a:rPr>
-              <a:t>AV · milestone decisions</a:t>
-            </a:r>
-          </a:p>
-          <a:p>
-            <a:pPr/>
-            <a:r>
-              <a:rPr>
-                <a:solidFill>
-                  <a:srgbClr val="333333"/>
-                </a:solidFill>
-              </a:rPr>
-              <a:t>Friday · your edits</a:t>
-            </a:r>
-          </a:p>
         </p:txBody>
       </p:sp>
+      <p:pic>
+        <p:nvPicPr>
+          <p:cNvPr id="81" name="Picture 80" descr="slide03-outcomes.png"/>
+          <p:cNvPicPr>
+            <a:picLocks noChangeAspect="1"/>
+          </p:cNvPicPr>
+          <p:nvPr/>
+        </p:nvPicPr>
+        <p:blipFill>
+          <a:blip r:embed="rId3"/>
+          <a:stretch>
+            <a:fillRect/>
+          </a:stretch>
+        </p:blipFill>
+        <p:spPr>
+          <a:xfrm>
+            <a:off x="411480" y="1143000"/>
+            <a:ext cx="11155680" cy="811008"/>
+          </a:xfrm>
+          <a:prstGeom prst="rect">
+            <a:avLst/>
+          </a:prstGeom>
+        </p:spPr>
+      </p:pic>
     </p:spTree>
   </p:cSld>
   <p:clrMapOvr>
@@ -6777,7 +6758,7 @@
           </a:bodyPr>
           <a:lstStyle/>
           <a:p>
-            <a:pPr marL="457200" marR="0" indent="-307975" algn="l" rtl="0">
+            <a:pPr marL="457200" marR="0" lvl="0" indent="-307975" algn="l" rtl="0">
               <a:lnSpc>
                 <a:spcPct val="115000"/>
               </a:lnSpc>
@@ -6794,14 +6775,6 @@
               <a:buFont typeface="Arial"/>
               <a:buChar char="●"/>
             </a:pPr>
-            <a:r>
-              <a:rPr>
-                <a:solidFill>
-                  <a:srgbClr val="333333"/>
-                </a:solidFill>
-              </a:rPr>
-              <a:t>Scope aligned?</a:t>
-            </a:r>
             <a:endParaRPr sz="1250" b="0" i="0" u="none" strike="noStrike" cap="none">
               <a:solidFill>
                 <a:schemeClr val="dk1"/>
@@ -6812,30 +6785,32 @@
               <a:sym typeface="Arial"/>
             </a:endParaRPr>
           </a:p>
-          <a:p>
-            <a:pPr/>
-            <a:r>
-              <a:rPr>
-                <a:solidFill>
-                  <a:srgbClr val="333333"/>
-                </a:solidFill>
-              </a:rPr>
-              <a:t>Program chair?</a:t>
-            </a:r>
-          </a:p>
-          <a:p>
-            <a:pPr/>
-            <a:r>
-              <a:rPr>
-                <a:solidFill>
-                  <a:srgbClr val="333333"/>
-                </a:solidFill>
-              </a:rPr>
-              <a:t>Backup deck · OCP</a:t>
-            </a:r>
-          </a:p>
         </p:txBody>
       </p:sp>
+      <p:pic>
+        <p:nvPicPr>
+          <p:cNvPr id="92" name="Picture 91" descr="slide04-sponsor.png"/>
+          <p:cNvPicPr>
+            <a:picLocks noChangeAspect="1"/>
+          </p:cNvPicPr>
+          <p:nvPr/>
+        </p:nvPicPr>
+        <p:blipFill>
+          <a:blip r:embed="rId3"/>
+          <a:stretch>
+            <a:fillRect/>
+          </a:stretch>
+        </p:blipFill>
+        <p:spPr>
+          <a:xfrm>
+            <a:off x="411480" y="1143000"/>
+            <a:ext cx="11155680" cy="849725"/>
+          </a:xfrm>
+          <a:prstGeom prst="rect">
+            <a:avLst/>
+          </a:prstGeom>
+        </p:spPr>
+      </p:pic>
     </p:spTree>
   </p:cSld>
   <p:clrMapOvr>

</xml_diff>

<commit_message>
Make A3 and B6 markdown the deck source of truth.
Build reads manager-arch-vision-a3.md and b6.md for on-slide copy, notes, and diagram labels; add aligned renderer and shared parser. Split B6 reference out and regenerate decks.

Co-authored-by: Cursor <cursoragent@cursor.com>
</commit_message>
<xml_diff>
--- a/dt100/manager-arch-vision-a3.pptx
+++ b/dt100/manager-arch-vision-a3.pptx
@@ -1804,12 +1804,7 @@
           <a:lstStyle/>
           <a:p>
             <a:r>
-              <a:t>COVER (if asked)</a:t>
-            </a:r>
-          </a:p>
-          <a:p>
-            <a:r>
-              <a:t>Arch vision review. Four slides + B6 backup. Confidential — Upscale AI.</a:t>
+              <a:t>Arch vision review. Upscale confidential. Main deck is four slides plus B6 backup.</a:t>
             </a:r>
           </a:p>
         </p:txBody>
@@ -1970,41 +1965,61 @@
           <a:lstStyle/>
           <a:p>
             <a:r>
-              <a:t>BEFORE SLIDE 1 (~20 s)</a:t>
+              <a:t>Sponsor is you — your name is not on this deck.</a:t>
             </a:r>
           </a:p>
+          <a:p/>
           <a:p>
             <a:r>
-              <a:t>Sponsor is you — name not on deck. I am Diwakar. Align: done and validated bar + my Dynamic Switch-Buffer Management (DBM) at CSB — ESUN analogy to DLB; not Rupa datapath arch). If slides 1-2 wrong, fix before B6. Flow: 1-2 → B6 → 3-4.</a:t>
+              <a:t>I am Diwakar. I am here to align on two things: your done and validated bar before tape-out (product, mgmt, datapath AV, SDK/SAI), and my scope: Dynamic Switch-Buffer Management (DBM — same ESUN-world idea as DLB, but at Switch-Buffer / CSB, not fabric load balancing). Buffer carving at CSB; queues, PFC, WRED/ECN/Pause via SDK/SAI — Rupa owns datapath architecture.</a:t>
             </a:r>
           </a:p>
           <a:p/>
           <a:p>
             <a:r>
-              <a:t>SLIDE 1 — do not read bullets</a:t>
+              <a:t>If slide one or two is off, tell me now; we fix that before B6, not after.</a:t>
             </a:r>
           </a:p>
+          <a:p/>
           <a:p>
             <a:r>
-              <a:t>His words: no one has looked at CSB + buffer carving — complex, needs datapath depth. He trusts I deliver CSB/carve by understanding datapath; Rupa owns datapath arch.</a:t>
+              <a:t>Flow: slides 1–2 → B6 (his pipeline slide — you point carve, don’t reframe Rupa’s map) → slides 3–4.</a:t>
             </a:r>
           </a:p>
           <a:p/>
           <a:p>
             <a:r>
-              <a:t>DBM (your label, ESUN-world pair to DLB) = dynamic Switch-Buffer management at CSB: carve, queues, PFC, WRED/ECN/Pause via SDK/SAI. Rupa owns datapath arch; her pipeline slide in B6 is her seed.</a:t>
+              <a:t>Point at slide: Title is DBM; subtitle is his ink — buffer carving at CSB (at = in that block, not owning full datapath).</a:t>
             </a:r>
           </a:p>
           <a:p/>
           <a:p>
             <a:r>
-              <a:t>Story A on slide: done and validated · product · mgmt · AV · SDK/SAI · C-model→silicon. Today: scope only.</a:t>
+              <a:t>DBM (spoken once): Pairs with DLB in ESUN scale-up vocabulary — equivalent branding, different layer (buffers/CSB, not ECMP/fabric).</a:t>
             </a:r>
           </a:p>
           <a:p/>
           <a:p>
             <a:r>
-              <a:t>INTO B6 (~5 s): his pipeline map — CSB + carve; do not own Rupa framing.</a:t>
+              <a:t>His words: no one has looked at CSB and buffer carving. You have confidence I can deliver by understanding datapath; Rupa owns datapath architecture. Her pipeline slide in B6 is a seed for her work — you walk it; you don’t own pkt-format / L2-L3 path framing.</a:t>
+            </a:r>
+          </a:p>
+          <a:p/>
+          <a:p>
+            <a:r>
+              <a:t>Story A on the slide: done and validated · product · mgmt · AV · SDK/SAI · C-model → emulation → silicon. I contribute; I do not own the full bar.</a:t>
+            </a:r>
+          </a:p>
+          <a:p/>
+          <a:p>
+            <a:r>
+              <a:t>Today: align on scope, not full HW sign-off or fifty-page packs.</a:t>
+            </a:r>
+          </a:p>
+          <a:p/>
+          <a:p>
+            <a:r>
+              <a:t>B6 is the how — whole pipe, owners, my wedge on QoSMAP and Queue. I will not read every row unless you want detail.</a:t>
             </a:r>
           </a:p>
         </p:txBody>
@@ -2165,24 +2180,25 @@
           <a:lstStyle/>
           <a:p>
             <a:r>
-              <a:t>SLIDE 2 — do not read bullets</a:t>
+              <a:t>Program (his language): SW done and validated before tape-out — product, mgmt plane, datapath AV, SDK/SAI, milestones on the path to silicon.</a:t>
             </a:r>
           </a:p>
+          <a:p/>
           <a:p>
             <a:r>
-              <a:t>Program: SW done and validated — product, AV, SDK/SAI, path to silicon.</a:t>
+              <a:t>My lane: QoS RM — QoSMAP, Queue, buffer carving. Not L2/L3, ECMP, or SDK programs.</a:t>
             </a:r>
           </a:p>
           <a:p/>
           <a:p>
             <a:r>
-              <a:t>Lane: QoS RM — QoSMAP, Queue, buffer carving. Peers: L2/L3 Shafi, ECMP Tippanna, SDK, Rupa.</a:t>
+              <a:t>Peers: Shafi on L2-FBD / ACL, Tippanna on ECMP / AV, SDK leads, Rupa on datapath / ESUN — names on B6.</a:t>
             </a:r>
           </a:p>
           <a:p/>
           <a:p>
             <a:r>
-              <a:t>If OK → open B6 (his pipeline slide — Rupa seed; point CSB + carve).</a:t>
+              <a:t>If this matches your expectation, we open B6 — his pipeline slide; you anchor CSB, QoSMAP, Queue, carve.</a:t>
             </a:r>
           </a:p>
         </p:txBody>
@@ -2343,30 +2359,31 @@
           <a:lstStyle/>
           <a:p>
             <a:r>
-              <a:t>SLIDE 3 — close after B6</a:t>
+              <a:t>Outcome: You get a 2-pager machine — Cx in ~two weeks: decisions, validation gates, open issues — not a fifty-page arch dump.</a:t>
             </a:r>
           </a:p>
+          <a:p/>
           <a:p>
             <a:r>
-              <a:t>Outcome: Cx 2-pager ~2 weeks — decisions + validation gates, not 50-page dump.</a:t>
+              <a:t>For him: done and validated clarity at milestones; AV at gates; thin read he can use upward (Executive review on cover is intentional).</a:t>
             </a:r>
           </a:p>
           <a:p/>
           <a:p>
             <a:r>
-              <a:t>Instill closed-loop SW-HW validation (use-case → models → tape-out) — tactical verbal only; see dt100/README.md Private prep.</a:t>
+              <a:t>~two weeks: First Cx drop — gates v0 + CSB / carve HWv1 scope inside the 2-pager, not as a separate QoS-only promise.</a:t>
             </a:r>
           </a:p>
           <a:p/>
           <a:p>
             <a:r>
-              <a:t>Thin read usable upward. Fri edits. CSB/carve HWv1 inside Cx, not headline.</a:t>
+              <a:t>This week: 1–2, B6, Friday on his edits.</a:t>
             </a:r>
           </a:p>
           <a:p/>
           <a:p>
             <a:r>
-              <a:t>AFTER B6 (~5 s): slides 3-4 — outcomes and Sponsor asks.</a:t>
+              <a:t>Last two slides — outcomes and what I need from you as Sponsor.</a:t>
             </a:r>
           </a:p>
         </p:txBody>
@@ -2527,24 +2544,37 @@
           <a:lstStyle/>
           <a:p>
             <a:r>
-              <a:t>SLIDE 4</a:t>
+              <a:t>Are slides 1–2 right? If not, we fix before treating B6 as agreed.</a:t>
             </a:r>
           </a:p>
+          <a:p/>
           <a:p>
             <a:r>
-              <a:t>1-2 right? Who owns slices (B6 names).</a:t>
+              <a:t>Confirm who owns which slice — B6 owner slide has names.</a:t>
             </a:r>
           </a:p>
           <a:p/>
           <a:p>
             <a:r>
-              <a:t>Optional spoken: who chairs done-and-validated program — he Sponsor or I drive?</a:t>
+              <a:t>Program chair (spoken, optional): Are you comfortable with me driving the done and validated program with you as Sponsor, or do you want to chair that yourself?</a:t>
             </a:r>
           </a:p>
           <a:p/>
           <a:p>
             <a:r>
-              <a:t>OCP: I coordinate datapath; he owns external. Format + escalate on gates.</a:t>
+              <a:t>OCP / vendors: I coordinate with datapath; you own company position externally.</a:t>
+            </a:r>
+          </a:p>
+          <a:p/>
+          <a:p>
+            <a:r>
+              <a:t>Format: PDF async, live, or Friday follow-up — your call.</a:t>
+            </a:r>
+          </a:p>
+          <a:p/>
+          <a:p>
+            <a:r>
+              <a:t>Escalation: Step in if architects stall on validation gates.</a:t>
             </a:r>
           </a:p>
         </p:txBody>
@@ -3590,7 +3620,7 @@
                 <a:cs typeface="Arial"/>
                 <a:sym typeface="Arial"/>
               </a:rPr>
-              <a:t>Arch vision</a:t>
+              <a:t>Architecture Vision</a:t>
             </a:r>
             <a:endParaRPr sz="1950" b="0" i="1" u="none" strike="noStrike" cap="none">
               <a:solidFill>
@@ -3696,7 +3726,7 @@
                 <a:cs typeface="Calibri"/>
                 <a:sym typeface="Calibri"/>
               </a:rPr>
-              <a:t>Executive review</a:t>
+              <a:t>End-to-end datapath hardware–software validation</a:t>
             </a:r>
             <a:endParaRPr sz="1100" b="0" i="0" u="none" strike="noStrike" cap="none">
               <a:solidFill>
@@ -3762,7 +3792,7 @@
                 <a:cs typeface="Calibri"/>
                 <a:sym typeface="Calibri"/>
               </a:rPr>
-              <a:t>Confidential — Upscale AI</a:t>
+              <a:t>For Executive Review · Confidential — Upscale AI</a:t>
             </a:r>
             <a:endParaRPr sz="1000" b="0" i="0" u="none" strike="noStrike" cap="none">
               <a:solidFill>
@@ -4587,15 +4617,15 @@
           </a:bodyPr>
           <a:lstStyle/>
           <a:p>
-            <a:pPr marL="0" marR="0" lvl="0" indent="0" algn="ctr" rtl="0">
-              <a:lnSpc>
-                <a:spcPct val="100000"/>
-              </a:lnSpc>
-              <a:spcBef>
-                <a:spcPts val="0"/>
-              </a:spcBef>
-              <a:spcAft>
-                <a:spcPts val="0"/>
+            <a:pPr marL="0" marR="0" indent="0" algn="ctr" rtl="0">
+              <a:lnSpc>
+                <a:spcPct val="100000"/>
+              </a:lnSpc>
+              <a:spcBef>
+                <a:spcPts val="0"/>
+              </a:spcBef>
+              <a:spcAft>
+                <a:spcPts val="200"/>
               </a:spcAft>
               <a:buClr>
                 <a:srgbClr val="FFE19E"/>
@@ -4605,16 +4635,13 @@
               <a:buNone/>
             </a:pPr>
             <a:r>
-              <a:rPr lang="en-US" sz="2200" b="1" i="0" u="none" strike="noStrike" cap="none">
+              <a:rPr sz="1900">
                 <a:solidFill>
                   <a:srgbClr val="FFE19E"/>
                 </a:solidFill>
                 <a:latin typeface="Calibri"/>
-                <a:ea typeface="Calibri"/>
-                <a:cs typeface="Calibri"/>
-                <a:sym typeface="Calibri"/>
               </a:rPr>
-              <a:t>Dynamic Switch-Buffer Management</a:t>
+              <a:t>Dynamic</a:t>
             </a:r>
             <a:endParaRPr sz="2200" b="0" i="0" u="none" strike="noStrike" cap="none">
               <a:solidFill>
@@ -4627,44 +4654,36 @@
             </a:endParaRPr>
           </a:p>
           <a:p>
-            <a:pPr marL="0" marR="0" lvl="0" indent="0" algn="ctr" rtl="0">
-              <a:lnSpc>
-                <a:spcPct val="100000"/>
-              </a:lnSpc>
-              <a:spcBef>
-                <a:spcPts val="0"/>
-              </a:spcBef>
-              <a:spcAft>
-                <a:spcPts val="0"/>
-              </a:spcAft>
-              <a:buClr>
-                <a:srgbClr val="FFE19E"/>
-              </a:buClr>
-              <a:buSzPts val="2200"/>
-              <a:buFont typeface="Calibri"/>
-              <a:buNone/>
+            <a:pPr algn="ctr">
+              <a:spcAft>
+                <a:spcPts val="200"/>
+              </a:spcAft>
             </a:pPr>
             <a:r>
-              <a:rPr lang="en-US" sz="2200" b="1" i="0" u="none" strike="noStrike" cap="none">
+              <a:rPr sz="1900">
                 <a:solidFill>
                   <a:srgbClr val="FFE19E"/>
                 </a:solidFill>
                 <a:latin typeface="Calibri"/>
-                <a:ea typeface="Calibri"/>
-                <a:cs typeface="Calibri"/>
-                <a:sym typeface="Calibri"/>
               </a:rPr>
-              <a:t/>
+              <a:t>Switch-Buffer</a:t>
             </a:r>
-            <a:endParaRPr sz="2200" b="0" i="0" u="none" strike="noStrike" cap="none">
-              <a:solidFill>
-                <a:schemeClr val="dk1"/>
-              </a:solidFill>
-              <a:latin typeface="Calibri"/>
-              <a:ea typeface="Calibri"/>
-              <a:cs typeface="Calibri"/>
-              <a:sym typeface="Calibri"/>
-            </a:endParaRPr>
+          </a:p>
+          <a:p>
+            <a:pPr algn="ctr">
+              <a:spcAft>
+                <a:spcPts val="200"/>
+              </a:spcAft>
+            </a:pPr>
+            <a:r>
+              <a:rPr sz="1900">
+                <a:solidFill>
+                  <a:srgbClr val="FFE19E"/>
+                </a:solidFill>
+                <a:latin typeface="Calibri"/>
+              </a:rPr>
+              <a:t>Management</a:t>
+            </a:r>
           </a:p>
         </p:txBody>
       </p:sp>
@@ -4948,30 +4967,6 @@
           </a:p>
         </p:txBody>
       </p:sp>
-      <p:pic>
-        <p:nvPicPr>
-          <p:cNvPr id="38" name="Picture 37" descr="slide00-cover.png"/>
-          <p:cNvPicPr>
-            <a:picLocks noChangeAspect="1"/>
-          </p:cNvPicPr>
-          <p:nvPr/>
-        </p:nvPicPr>
-        <p:blipFill>
-          <a:blip r:embed="rId3"/>
-          <a:stretch>
-            <a:fillRect/>
-          </a:stretch>
-        </p:blipFill>
-        <p:spPr>
-          <a:xfrm>
-            <a:off x="502920" y="1874519"/>
-            <a:ext cx="5303520" cy="675516"/>
-          </a:xfrm>
-          <a:prstGeom prst="rect">
-            <a:avLst/>
-          </a:prstGeom>
-        </p:spPr>
-      </p:pic>
     </p:spTree>
   </p:cSld>
   <p:clrMapOvr>
@@ -5030,15 +5025,15 @@
           </a:bodyPr>
           <a:lstStyle/>
           <a:p>
-            <a:pPr marL="0" marR="0" lvl="0" indent="0" algn="l" rtl="0">
-              <a:lnSpc>
-                <a:spcPct val="100000"/>
-              </a:lnSpc>
-              <a:spcBef>
-                <a:spcPts val="0"/>
-              </a:spcBef>
-              <a:spcAft>
-                <a:spcPts val="0"/>
+            <a:pPr marL="0" marR="0" indent="0" algn="l" rtl="0">
+              <a:lnSpc>
+                <a:spcPct val="100000"/>
+              </a:lnSpc>
+              <a:spcBef>
+                <a:spcPts val="0"/>
+              </a:spcBef>
+              <a:spcAft>
+                <a:spcPts val="300"/>
               </a:spcAft>
               <a:buClr>
                 <a:srgbClr val="051830"/>
@@ -5048,16 +5043,13 @@
               <a:buNone/>
             </a:pPr>
             <a:r>
-              <a:rPr lang="en-US" sz="3000" b="0" i="0" u="none" strike="noStrike" cap="none">
+              <a:rPr sz="1900">
                 <a:solidFill>
                   <a:srgbClr val="051830"/>
                 </a:solidFill>
                 <a:latin typeface="Calibri"/>
-                <a:ea typeface="Calibri"/>
-                <a:cs typeface="Calibri"/>
-                <a:sym typeface="Calibri"/>
               </a:rPr>
-              <a:t>Dynamic Switch-Buffer Management</a:t>
+              <a:t>Dynamic</a:t>
             </a:r>
             <a:endParaRPr sz="3000" b="0" i="0" u="none" strike="noStrike" cap="none">
               <a:solidFill>
@@ -5068,6 +5060,54 @@
               <a:cs typeface="Calibri"/>
               <a:sym typeface="Calibri"/>
             </a:endParaRPr>
+          </a:p>
+          <a:p>
+            <a:pPr>
+              <a:spcAft>
+                <a:spcPts val="300"/>
+              </a:spcAft>
+            </a:pPr>
+            <a:r>
+              <a:rPr sz="1900">
+                <a:solidFill>
+                  <a:srgbClr val="051830"/>
+                </a:solidFill>
+                <a:latin typeface="Calibri"/>
+              </a:rPr>
+              <a:t>Switch-Buffer</a:t>
+            </a:r>
+          </a:p>
+          <a:p>
+            <a:pPr>
+              <a:spcAft>
+                <a:spcPts val="300"/>
+              </a:spcAft>
+            </a:pPr>
+            <a:r>
+              <a:rPr sz="1900">
+                <a:solidFill>
+                  <a:srgbClr val="051830"/>
+                </a:solidFill>
+                <a:latin typeface="Calibri"/>
+              </a:rPr>
+              <a:t>Management</a:t>
+            </a:r>
+          </a:p>
+          <a:p>
+            <a:pPr>
+              <a:spcAft>
+                <a:spcPts val="300"/>
+              </a:spcAft>
+            </a:pPr>
+            <a:r>
+              <a:rPr sz="1300">
+                <a:solidFill>
+                  <a:srgbClr val="556677"/>
+                </a:solidFill>
+                <a:latin typeface="Arial"/>
+              </a:rPr>
+              <a:t>Buffer carving at CSB</a:t>
+            </a:r>
           </a:p>
         </p:txBody>
       </p:sp>
@@ -5360,7 +5400,7 @@
         <p:spPr>
           <a:xfrm>
             <a:off x="411475" y="795525"/>
-            <a:ext cx="8321100" cy="3917400"/>
+            <a:ext cx="0" cy="0"/>
           </a:xfrm>
           <a:prstGeom prst="rect">
             <a:avLst/>
@@ -5376,7 +5416,7 @@
           </a:bodyPr>
           <a:lstStyle/>
           <a:p>
-            <a:pPr marL="457200" marR="0" indent="-307975" algn="l" rtl="0">
+            <a:pPr marL="457200" marR="0" lvl="0" indent="-307975" algn="l" rtl="0">
               <a:lnSpc>
                 <a:spcPct val="115000"/>
               </a:lnSpc>
@@ -5393,14 +5433,6 @@
               <a:buFont typeface="Arial"/>
               <a:buChar char="●"/>
             </a:pPr>
-            <a:r>
-              <a:rPr>
-                <a:solidFill>
-                  <a:srgbClr val="333333"/>
-                </a:solidFill>
-              </a:rPr>
-              <a:t>Buffer carving at CSB</a:t>
-            </a:r>
             <a:endParaRPr sz="1250" b="0" i="0" u="none" strike="noStrike" cap="none">
               <a:solidFill>
                 <a:schemeClr val="dk1"/>
@@ -5410,9 +5442,6 @@
               <a:cs typeface="Arial"/>
               <a:sym typeface="Arial"/>
             </a:endParaRPr>
-          </a:p>
-          <a:p>
-            <a:pPr/>
           </a:p>
         </p:txBody>
       </p:sp>
@@ -5432,8 +5461,8 @@
         </p:blipFill>
         <p:spPr>
           <a:xfrm>
-            <a:off x="411480" y="1143000"/>
-            <a:ext cx="11155680" cy="2121284"/>
+            <a:off x="2743391" y="1920240"/>
+            <a:ext cx="3657218" cy="3977639"/>
           </a:xfrm>
           <a:prstGeom prst="rect">
             <a:avLst/>
@@ -5498,15 +5527,15 @@
           </a:bodyPr>
           <a:lstStyle/>
           <a:p>
-            <a:pPr marL="0" marR="0" lvl="0" indent="0" algn="l" rtl="0">
-              <a:lnSpc>
-                <a:spcPct val="100000"/>
-              </a:lnSpc>
-              <a:spcBef>
-                <a:spcPts val="0"/>
-              </a:spcBef>
-              <a:spcAft>
-                <a:spcPts val="0"/>
+            <a:pPr marL="0" marR="0" indent="0" algn="l" rtl="0">
+              <a:lnSpc>
+                <a:spcPct val="100000"/>
+              </a:lnSpc>
+              <a:spcBef>
+                <a:spcPts val="0"/>
+              </a:spcBef>
+              <a:spcAft>
+                <a:spcPts val="300"/>
               </a:spcAft>
               <a:buClr>
                 <a:srgbClr val="051830"/>
@@ -5516,14 +5545,11 @@
               <a:buNone/>
             </a:pPr>
             <a:r>
-              <a:rPr lang="en-US" sz="3000" b="0" i="0" u="none" strike="noStrike" cap="none">
+              <a:rPr sz="2600">
                 <a:solidFill>
                   <a:srgbClr val="051830"/>
                 </a:solidFill>
                 <a:latin typeface="Calibri"/>
-                <a:ea typeface="Calibri"/>
-                <a:cs typeface="Calibri"/>
-                <a:sym typeface="Calibri"/>
               </a:rPr>
               <a:t>SW done and validated before tape-out</a:t>
             </a:r>
@@ -5828,7 +5854,7 @@
         <p:spPr>
           <a:xfrm>
             <a:off x="411475" y="795525"/>
-            <a:ext cx="8321100" cy="3253500"/>
+            <a:ext cx="0" cy="0"/>
           </a:xfrm>
           <a:prstGeom prst="rect">
             <a:avLst/>
@@ -5889,8 +5915,8 @@
         </p:blipFill>
         <p:spPr>
           <a:xfrm>
-            <a:off x="411480" y="1143000"/>
-            <a:ext cx="11155680" cy="3232156"/>
+            <a:off x="1257301" y="1920240"/>
+            <a:ext cx="6629398" cy="3977639"/>
           </a:xfrm>
           <a:prstGeom prst="rect">
             <a:avLst/>
@@ -5955,15 +5981,15 @@
           </a:bodyPr>
           <a:lstStyle/>
           <a:p>
-            <a:pPr marL="0" marR="0" lvl="0" indent="0" algn="l" rtl="0">
-              <a:lnSpc>
-                <a:spcPct val="100000"/>
-              </a:lnSpc>
-              <a:spcBef>
-                <a:spcPts val="0"/>
-              </a:spcBef>
-              <a:spcAft>
-                <a:spcPts val="0"/>
+            <a:pPr marL="0" marR="0" indent="0" algn="l" rtl="0">
+              <a:lnSpc>
+                <a:spcPct val="100000"/>
+              </a:lnSpc>
+              <a:spcBef>
+                <a:spcPts val="0"/>
+              </a:spcBef>
+              <a:spcAft>
+                <a:spcPts val="300"/>
               </a:spcAft>
               <a:buClr>
                 <a:srgbClr val="051830"/>
@@ -5973,14 +5999,11 @@
               <a:buNone/>
             </a:pPr>
             <a:r>
-              <a:rPr lang="en-US" sz="3000" b="0" i="0" u="none" strike="noStrike" cap="none">
+              <a:rPr sz="2600">
                 <a:solidFill>
                   <a:srgbClr val="051830"/>
                 </a:solidFill>
                 <a:latin typeface="Calibri"/>
-                <a:ea typeface="Calibri"/>
-                <a:cs typeface="Calibri"/>
-                <a:sym typeface="Calibri"/>
               </a:rPr>
               <a:t>What you get</a:t>
             </a:r>
@@ -6285,7 +6308,7 @@
         <p:spPr>
           <a:xfrm>
             <a:off x="411475" y="795525"/>
-            <a:ext cx="8321100" cy="3032400"/>
+            <a:ext cx="0" cy="0"/>
           </a:xfrm>
           <a:prstGeom prst="rect">
             <a:avLst/>
@@ -6346,8 +6369,8 @@
         </p:blipFill>
         <p:spPr>
           <a:xfrm>
-            <a:off x="411480" y="1143000"/>
-            <a:ext cx="11155680" cy="811008"/>
+            <a:off x="2931224" y="1920240"/>
+            <a:ext cx="3281552" cy="3977639"/>
           </a:xfrm>
           <a:prstGeom prst="rect">
             <a:avLst/>
@@ -6412,15 +6435,15 @@
           </a:bodyPr>
           <a:lstStyle/>
           <a:p>
-            <a:pPr marL="0" marR="0" lvl="0" indent="0" algn="l" rtl="0">
-              <a:lnSpc>
-                <a:spcPct val="100000"/>
-              </a:lnSpc>
-              <a:spcBef>
-                <a:spcPts val="0"/>
-              </a:spcBef>
-              <a:spcAft>
-                <a:spcPts val="0"/>
+            <a:pPr marL="0" marR="0" indent="0" algn="l" rtl="0">
+              <a:lnSpc>
+                <a:spcPct val="100000"/>
+              </a:lnSpc>
+              <a:spcBef>
+                <a:spcPts val="0"/>
+              </a:spcBef>
+              <a:spcAft>
+                <a:spcPts val="300"/>
               </a:spcAft>
               <a:buClr>
                 <a:srgbClr val="051830"/>
@@ -6430,14 +6453,11 @@
               <a:buNone/>
             </a:pPr>
             <a:r>
-              <a:rPr lang="en-US" sz="3000" b="0" i="0" u="none" strike="noStrike" cap="none">
+              <a:rPr sz="2600">
                 <a:solidFill>
                   <a:srgbClr val="051830"/>
                 </a:solidFill>
                 <a:latin typeface="Calibri"/>
-                <a:ea typeface="Calibri"/>
-                <a:cs typeface="Calibri"/>
-                <a:sym typeface="Calibri"/>
               </a:rPr>
               <a:t>What I need from you</a:t>
             </a:r>
@@ -6742,7 +6762,7 @@
         <p:spPr>
           <a:xfrm>
             <a:off x="411475" y="795525"/>
-            <a:ext cx="8622000" cy="2811000"/>
+            <a:ext cx="0" cy="0"/>
           </a:xfrm>
           <a:prstGeom prst="rect">
             <a:avLst/>
@@ -6803,8 +6823,8 @@
         </p:blipFill>
         <p:spPr>
           <a:xfrm>
-            <a:off x="411480" y="1143000"/>
-            <a:ext cx="11155680" cy="849725"/>
+            <a:off x="2931224" y="1920240"/>
+            <a:ext cx="3281552" cy="3977639"/>
           </a:xfrm>
           <a:prstGeom prst="rect">
             <a:avLst/>

</xml_diff>

<commit_message>
Replace Mermaid deck pipeline with fail-loud Python validation.
Diagrams render from manager-arch-vision-a3.md via PyMuPDF only; the build
stops on missing assets instead of silently degrading slides or pptx output.

Co-authored-by: Cursor <cursoragent@cursor.com>
</commit_message>
<xml_diff>
--- a/dt100/manager-arch-vision-a3.pptx
+++ b/dt100/manager-arch-vision-a3.pptx
@@ -5020,7 +5020,7 @@
           </a:ln>
         </p:spPr>
         <p:txBody>
-          <a:bodyPr spcFirstLastPara="1" wrap="square" lIns="91425" tIns="45700" rIns="91425" bIns="45700" anchor="t" anchorCtr="0">
+          <a:bodyPr spcFirstLastPara="1" wrap="none" lIns="91425" tIns="45700" rIns="91425" bIns="45700" anchor="t" anchorCtr="0">
             <a:noAutofit/>
           </a:bodyPr>
           <a:lstStyle/>
@@ -5043,13 +5043,13 @@
               <a:buNone/>
             </a:pPr>
             <a:r>
-              <a:rPr sz="1900">
+              <a:rPr sz="2600">
                 <a:solidFill>
                   <a:srgbClr val="051830"/>
                 </a:solidFill>
                 <a:latin typeface="Calibri"/>
               </a:rPr>
-              <a:t>Dynamic</a:t>
+              <a:t>Dynamic Switch-Buffer Management</a:t>
             </a:r>
             <a:endParaRPr sz="3000" b="0" i="0" u="none" strike="noStrike" cap="none">
               <a:solidFill>
@@ -5068,45 +5068,13 @@
               </a:spcAft>
             </a:pPr>
             <a:r>
-              <a:rPr sz="1900">
-                <a:solidFill>
-                  <a:srgbClr val="051830"/>
-                </a:solidFill>
-                <a:latin typeface="Calibri"/>
-              </a:rPr>
-              <a:t>Switch-Buffer</a:t>
-            </a:r>
-          </a:p>
-          <a:p>
-            <a:pPr>
-              <a:spcAft>
-                <a:spcPts val="300"/>
-              </a:spcAft>
-            </a:pPr>
-            <a:r>
-              <a:rPr sz="1900">
-                <a:solidFill>
-                  <a:srgbClr val="051830"/>
-                </a:solidFill>
-                <a:latin typeface="Calibri"/>
-              </a:rPr>
-              <a:t>Management</a:t>
-            </a:r>
-          </a:p>
-          <a:p>
-            <a:pPr>
-              <a:spcAft>
-                <a:spcPts val="300"/>
-              </a:spcAft>
-            </a:pPr>
-            <a:r>
               <a:rPr sz="1300">
                 <a:solidFill>
                   <a:srgbClr val="556677"/>
                 </a:solidFill>
                 <a:latin typeface="Arial"/>
               </a:rPr>
-              <a:t>Buffer carving at CSB</a:t>
+              <a:t>Buffer carving at Central Scheduler Block</a:t>
             </a:r>
           </a:p>
         </p:txBody>
@@ -5461,8 +5429,8 @@
         </p:blipFill>
         <p:spPr>
           <a:xfrm>
-            <a:off x="2743391" y="1920240"/>
-            <a:ext cx="3657218" cy="3977639"/>
+            <a:off x="365760" y="1538547"/>
+            <a:ext cx="8412480" cy="3186545"/>
           </a:xfrm>
           <a:prstGeom prst="rect">
             <a:avLst/>
@@ -5522,7 +5490,7 @@
           </a:ln>
         </p:spPr>
         <p:txBody>
-          <a:bodyPr spcFirstLastPara="1" wrap="square" lIns="91425" tIns="45700" rIns="91425" bIns="45700" anchor="t" anchorCtr="0">
+          <a:bodyPr spcFirstLastPara="1" wrap="none" lIns="91425" tIns="45700" rIns="91425" bIns="45700" anchor="t" anchorCtr="0">
             <a:noAutofit/>
           </a:bodyPr>
           <a:lstStyle/>
@@ -5915,8 +5883,8 @@
         </p:blipFill>
         <p:spPr>
           <a:xfrm>
-            <a:off x="1257301" y="1920240"/>
-            <a:ext cx="6629398" cy="3977639"/>
+            <a:off x="365760" y="1538547"/>
+            <a:ext cx="8412480" cy="3186545"/>
           </a:xfrm>
           <a:prstGeom prst="rect">
             <a:avLst/>
@@ -5976,7 +5944,7 @@
           </a:ln>
         </p:spPr>
         <p:txBody>
-          <a:bodyPr spcFirstLastPara="1" wrap="square" lIns="91425" tIns="45700" rIns="91425" bIns="45700" anchor="t" anchorCtr="0">
+          <a:bodyPr spcFirstLastPara="1" wrap="none" lIns="91425" tIns="45700" rIns="91425" bIns="45700" anchor="t" anchorCtr="0">
             <a:noAutofit/>
           </a:bodyPr>
           <a:lstStyle/>
@@ -6369,8 +6337,8 @@
         </p:blipFill>
         <p:spPr>
           <a:xfrm>
-            <a:off x="2931224" y="1920240"/>
-            <a:ext cx="3281552" cy="3977639"/>
+            <a:off x="365760" y="1538547"/>
+            <a:ext cx="8412480" cy="3186545"/>
           </a:xfrm>
           <a:prstGeom prst="rect">
             <a:avLst/>
@@ -6430,7 +6398,7 @@
           </a:ln>
         </p:spPr>
         <p:txBody>
-          <a:bodyPr spcFirstLastPara="1" wrap="square" lIns="91425" tIns="45700" rIns="91425" bIns="45700" anchor="t" anchorCtr="0">
+          <a:bodyPr spcFirstLastPara="1" wrap="none" lIns="91425" tIns="45700" rIns="91425" bIns="45700" anchor="t" anchorCtr="0">
             <a:noAutofit/>
           </a:bodyPr>
           <a:lstStyle/>
@@ -6823,8 +6791,8 @@
         </p:blipFill>
         <p:spPr>
           <a:xfrm>
-            <a:off x="2931224" y="1920240"/>
-            <a:ext cx="3281552" cy="3977639"/>
+            <a:off x="365760" y="1538547"/>
+            <a:ext cx="8412480" cy="3186545"/>
           </a:xfrm>
           <a:prstGeom prst="rect">
             <a:avLst/>

</xml_diff>

<commit_message>
Polish A3 deck copy and diagram layout for Guru meeting.
Reframe slides 3–4 to engineering checkpoints, tighten terminology, and rebuild diagrams with unified scaling, full-width spread boxes, and cleaner connectors.

Co-authored-by: Cursor <cursoragent@cursor.com>
</commit_message>
<xml_diff>
--- a/dt100/manager-arch-vision-a3.pptx
+++ b/dt100/manager-arch-vision-a3.pptx
@@ -1804,7 +1804,13 @@
           <a:lstStyle/>
           <a:p>
             <a:r>
-              <a:t>Arch vision review. Upscale confidential. Main deck is four slides plus B6 backup.</a:t>
+              <a:t>This deck sells me in the role — vision, draft plan, how I drive — not a document handoff.</a:t>
+            </a:r>
+          </a:p>
+          <a:p/>
+          <a:p>
+            <a:r>
+              <a:t>Left = your program bar (done and validated to tape-out). Right = my DRI wedge (DBM). Fri 11am close = mandate and marching orders for a 2–3 month sprint, if trust is there.</a:t>
             </a:r>
           </a:p>
         </p:txBody>
@@ -1971,55 +1977,49 @@
           <a:p/>
           <a:p>
             <a:r>
-              <a:t>I am Diwakar. I am here to align on two things: your done and validated bar before tape-out (product, mgmt, datapath AV, SDK/SAI), and my scope: Dynamic Switch-Buffer Management (DBM — same ESUN-world idea as DLB, but at Switch-Buffer / CSB, not fabric load balancing). Buffer carving at CSB; queues, PFC, WRED/ECN/Pause via SDK/SAI — Rupa owns datapath architecture.</a:t>
+              <a:t>I am Diwakar. You need someone you can trust to drive with little supervision — not get lost or stuck — while you guide at critical junctures. These slides show what I will do in that role: vision, plans, draft execution path.</a:t>
             </a:r>
           </a:p>
           <a:p/>
           <a:p>
             <a:r>
-              <a:t>If slide one or two is off, tell me now; we fix that before B6, not after.</a:t>
+              <a:t>Two alignments: (1) your done-and-validated bar — product, mgmt plane, architecture validation, SDK/SAI, C-model → emulation → silicon; (2) my wedge — Dynamic Switch-Buffer Management (DBM) at CSB (QoSMAP, Queue, buffer carving).</a:t>
             </a:r>
           </a:p>
           <a:p/>
           <a:p>
             <a:r>
-              <a:t>Flow: slides 1–2 → B6 (his pipeline slide — you point carve, don’t reframe Rupa’s map) → slides 3–4.</a:t>
+              <a:t>DBM (say once): ESUN-world pair to DLB — buffers/CSB layer, not ECMP/fabric. Rupa owns datapath architecture; I drive by understanding the pipe. Peers on B6: Shafi (L2/ACL), Tippanna (ECMP/AV), SDK leads, Rupa (datapath/OCP).</a:t>
             </a:r>
           </a:p>
           <a:p/>
           <a:p>
             <a:r>
-              <a:t>Point at slide: Title is DBM; subtitle is his ink — buffer carving at CSB (at = in that block, not owning full datapath).</a:t>
+              <a:t>Flow: slides 1–2 (situation + task) → B6 (vision + draft plan walk) → slides 3–4 (mandate + sponsor alignment).</a:t>
             </a:r>
           </a:p>
           <a:p/>
           <a:p>
             <a:r>
-              <a:t>DBM (spoken once): Pairs with DLB in ESUN scale-up vocabulary — equivalent branding, different layer (buffers/CSB, not ECMP/fabric).</a:t>
+              <a:t>What I will drive in your program bar — not owning product, mgmt, full AV, or SDK programs, but contributing with a clear wedge.</a:t>
             </a:r>
           </a:p>
           <a:p/>
           <a:p>
             <a:r>
-              <a:t>His words: no one has looked at CSB and buffer carving. You have confidence I can deliver by understanding datapath; Rupa owns datapath architecture. Her pipeline slide in B6 is a seed for her work — you walk it; you don’t own pkt-format / L2-L3 path framing.</a:t>
+              <a:t>Bottom band = my lane: QoS RM on QoSMAP, Queue, buffer carving at CSB. This is the draft scope I execute under your steer.</a:t>
             </a:r>
           </a:p>
           <a:p/>
           <a:p>
             <a:r>
-              <a:t>Story A on the slide: done and validated · product · mgmt · AV · SDK/SAI · C-model → emulation → silicon. I contribute; I do not own the full bar.</a:t>
+              <a:t>Selling: I have a bounded wedge and understand how it sits in the full tape-out path.</a:t>
             </a:r>
           </a:p>
           <a:p/>
           <a:p>
             <a:r>
-              <a:t>Today: align on scope, not full HW sign-off or fifty-page packs.</a:t>
-            </a:r>
-          </a:p>
-          <a:p/>
-          <a:p>
-            <a:r>
-              <a:t>B6 is the how — whole pipe, owners, my wedge on QoSMAP and Queue. I will not read every row unless you want detail.</a:t>
+              <a:t>B6 is not a deliverable — it is how I show vision, draft plans, and execution instinct. Walk it; steer me at junctures. Role-play the arch execution plan.</a:t>
             </a:r>
           </a:p>
         </p:txBody>
@@ -2180,25 +2180,19 @@
           <a:lstStyle/>
           <a:p>
             <a:r>
-              <a:t>Program (his language): SW done and validated before tape-out — product, mgmt plane, datapath AV, SDK/SAI, milestones on the path to silicon.</a:t>
+              <a:t>Can you trust this split? Column 1 = your org-level question. Column 2 = what I own and drive. Column 3 = peers I align with, not compete with.</a:t>
             </a:r>
           </a:p>
           <a:p/>
           <a:p>
             <a:r>
-              <a:t>My lane: QoS RM — QoSMAP, Queue, buffer carving. Not L2/L3, ECMP, or SDK programs.</a:t>
+              <a:t>Yes → B6 shows my vision and draft plan on the pipeline. No → we fix framing before any mandate.</a:t>
             </a:r>
           </a:p>
           <a:p/>
           <a:p>
             <a:r>
-              <a:t>Peers: Shafi on L2-FBD / ACL, Tippanna on ECMP / AV, SDK leads, Rupa on datapath / ESUN — names on B6.</a:t>
-            </a:r>
-          </a:p>
-          <a:p/>
-          <a:p>
-            <a:r>
-              <a:t>If this matches your expectation, we open B6 — his pipeline slide; you anchor CSB, QoSMAP, Queue, carve.</a:t>
+              <a:t>This slide is the trust checkpoint before you invest guidance in a 2–3 month sprint.</a:t>
             </a:r>
           </a:p>
         </p:txBody>
@@ -2359,31 +2353,25 @@
           <a:lstStyle/>
           <a:p>
             <a:r>
-              <a:t>Outcome: You get a 2-pager machine — Cx in ~two weeks: decisions, validation gates, open issues — not a fifty-page arch dump.</a:t>
+              <a:t>Fri 11am — if aligned, mandate for this sprint scope (not another deck).</a:t>
             </a:r>
           </a:p>
           <a:p/>
           <a:p>
             <a:r>
-              <a:t>For him: done and validated clarity at milestones; AV at gates; thin read he can use upward (Executive review on cover is intentional).</a:t>
+              <a:t>Window: 2–3 months on the tape-out path. SW ↔ HW: validation gates before silicon. AV · C-model / co-dev: architecture validation and HW–SW co-development cadence. Exit: SDK, SAI, mgmt plane working on silicon.</a:t>
             </a:r>
           </a:p>
           <a:p/>
           <a:p>
             <a:r>
-              <a:t>~two weeks: First Cx drop — gates v0 + CSB / carve HWv1 scope inside the 2-pager, not as a separate QoS-only promise.</a:t>
+              <a:t>Gururaj touch-in at gates; I drive day-to-day technical work. Depth follows redirect after mandate.</a:t>
             </a:r>
           </a:p>
           <a:p/>
           <a:p>
             <a:r>
-              <a:t>This week: 1–2, B6, Friday on his edits.</a:t>
-            </a:r>
-          </a:p>
-          <a:p/>
-          <a:p>
-            <a:r>
-              <a:t>Last two slides — outcomes and what I need from you as Sponsor.</a:t>
+              <a:t>Slide 4: four engineering checkpoints before Fri close. Mandate = permission to drive the sprint. Pipeline plan co-evolved on B6 — alignment, not a doc handoff.</a:t>
             </a:r>
           </a:p>
         </p:txBody>
@@ -2544,37 +2532,19 @@
           <a:lstStyle/>
           <a:p>
             <a:r>
-              <a:t>Are slides 1–2 right? If not, we fix before treating B6 as agreed.</a:t>
+              <a:t>Four checkpoints — technical, not a sign-off deck.</a:t>
             </a:r>
           </a:p>
           <a:p/>
           <a:p>
             <a:r>
-              <a:t>Confirm who owns which slice — B6 owner slide has names.</a:t>
+              <a:t>Scope: slides 1–2 — program bar + DBM at CSB framed correctly? Lane: QoSMAP, Queue, buffer carving vs peer DRIs. B6: logical pipeline and draft validation path. OCP: I align with Rupa on datapath standards; Gururaj carries company position externally (standards body, customer-facing).</a:t>
             </a:r>
           </a:p>
           <a:p/>
           <a:p>
             <a:r>
-              <a:t>Program chair (spoken, optional): Are you comfortable with me driving the done and validated program with you as Sponsor, or do you want to chair that yourself?</a:t>
-            </a:r>
-          </a:p>
-          <a:p/>
-          <a:p>
-            <a:r>
-              <a:t>OCP / vendors: I coordinate with datapath; you own company position externally.</a:t>
-            </a:r>
-          </a:p>
-          <a:p/>
-          <a:p>
-            <a:r>
-              <a:t>Format: PDF async, live, or Friday follow-up — your call.</a:t>
-            </a:r>
-          </a:p>
-          <a:p/>
-          <a:p>
-            <a:r>
-              <a:t>Escalation: Step in if architects stall on validation gates.</a:t>
+              <a:t>If aligned: Fri mandate for the 2–3 month sprint — AV/C-model, SDK/SAI/mgmt integration to tape-out.</a:t>
             </a:r>
           </a:p>
         </p:txBody>
@@ -3792,7 +3762,7 @@
                 <a:cs typeface="Calibri"/>
                 <a:sym typeface="Calibri"/>
               </a:rPr>
-              <a:t>For Executive Review · Confidential — Upscale AI</a:t>
+              <a:t>Architecture review · Confidential — Upscale AI</a:t>
             </a:r>
             <a:endParaRPr sz="1000" b="0" i="0" u="none" strike="noStrike" cap="none">
               <a:solidFill>
@@ -5074,7 +5044,7 @@
                 </a:solidFill>
                 <a:latin typeface="Arial"/>
               </a:rPr>
-              <a:t>Buffer carving at Central Scheduler Block</a:t>
+              <a:t>Buffer carving at Central Scheduler Block (CSB)</a:t>
             </a:r>
           </a:p>
         </p:txBody>
@@ -5973,7 +5943,7 @@
                 </a:solidFill>
                 <a:latin typeface="Calibri"/>
               </a:rPr>
-              <a:t>What you get</a:t>
+              <a:t>Sprint scope · Fri close</a:t>
             </a:r>
             <a:endParaRPr sz="3000" b="0" i="0" u="none" strike="noStrike" cap="none">
               <a:solidFill>
@@ -6427,7 +6397,7 @@
                 </a:solidFill>
                 <a:latin typeface="Calibri"/>
               </a:rPr>
-              <a:t>What I need from you</a:t>
+              <a:t>Alignment · Fri close</a:t>
             </a:r>
             <a:endParaRPr sz="3000" b="0" i="0" u="none" strike="noStrike" cap="none">
               <a:solidFill>

</xml_diff>

<commit_message>
Fix draft QoS slides for Guru review: visual read path and clean labels.
Remove internal A3/B6 from deck copy and notes; add numbered read-order arrows, my-lane and deliverable bounding boxes, compass prefetch band, and selective software wording. Add --a3-only build flag.

Co-authored-by: Cursor <cursoragent@cursor.com>
</commit_message>
<xml_diff>
--- a/dt100/manager-arch-vision-a3.pptx
+++ b/dt100/manager-arch-vision-a3.pptx
@@ -1810,7 +1810,7 @@
           <a:p/>
           <a:p>
             <a:r>
-              <a:t>Left = your program bar (done and validated to tape-out). Right = my DRI wedge (DBM). Fri 11am close = mandate and marching orders for a 2–3 month sprint, if trust is there.</a:t>
+              <a:t>Left = your program bar (done and validated to tape-out). Right = my DRI wedge (DBM). Close = mandate + **concrete draft in next few days** (Guru steer post-meeting).</a:t>
             </a:r>
           </a:p>
         </p:txBody>
@@ -1989,13 +1989,13 @@
           <a:p/>
           <a:p>
             <a:r>
-              <a:t>DBM (say once): ESUN-world pair to DLB — buffers/CSB layer, not ECMP/fabric. Rupa owns datapath architecture; I drive by understanding the pipe. Peers on B6: Shafi (L2/ACL), Tippanna (ECMP/AV), SDK leads, Rupa (datapath/OCP).</a:t>
+              <a:t>DBM (say once): ESUN-world pair to DLB — buffers/CSB layer, not ECMP/fabric. Rupa owns datapath architecture; I drive by understanding the pipe. Peer intersects: Shafi (L2/ACL), Tippanna (ECMP/AV), SDK leads, Rupa (datapath/OCP).</a:t>
             </a:r>
           </a:p>
           <a:p/>
           <a:p>
             <a:r>
-              <a:t>Flow: slides 1–2 (situation + task) → B6 (vision + draft plan walk) → slides 3–4 (mandate + sponsor alignment).</a:t>
+              <a:t>Flow: slides 1–2 (situation + task) → QoS buffer carving arch walk → slides 3–4 (mandate + alignment).</a:t>
             </a:r>
           </a:p>
           <a:p/>
@@ -2019,7 +2019,7 @@
           <a:p/>
           <a:p>
             <a:r>
-              <a:t>B6 is not a deliverable — it is how I show vision, draft plans, and execution instinct. Walk it; steer me at junctures. Role-play the arch execution plan.</a:t>
+              <a:t>Pipeline walk is not a deliverable — it is how I show vision, draft plans, and execution instinct. Walk it; steer me at junctures. Role-play the arch execution plan.</a:t>
             </a:r>
           </a:p>
         </p:txBody>
@@ -2180,19 +2180,19 @@
           <a:lstStyle/>
           <a:p>
             <a:r>
-              <a:t>Can you trust this split? Column 1 = your org-level question. Column 2 = what I own and drive. Column 3 = peers I align with, not compete with.</a:t>
+              <a:t>Walk order: three columns **left → right**, then **down** to Aligned → QoS buffer carving arch. **Read order** on-slide: numbered arrows 1 → 2 → 3 (Guru: visual learner — how to read).</a:t>
             </a:r>
           </a:p>
           <a:p/>
           <a:p>
             <a:r>
-              <a:t>Yes → B6 shows my vision and draft plan on the pipeline. No → we fix framing before any mandate.</a:t>
+              <a:t>**Aligned · Wed 1:1** — not a re-ask. Middle column = my lane (QoS buffer carve). Bottom band = **My deliverable** — compass prefetch for org framing (no N-E-W-S label on wall).</a:t>
             </a:r>
           </a:p>
           <a:p/>
           <a:p>
             <a:r>
-              <a:t>This slide is the trust checkpoint before you invest guidance in a 2–3 month sprint.</a:t>
+              <a:t>Yes → QoS buffer carving arch walk. No path grayed — closed at 1:1.</a:t>
             </a:r>
           </a:p>
         </p:txBody>
@@ -2353,25 +2353,25 @@
           <a:lstStyle/>
           <a:p>
             <a:r>
-              <a:t>Fri 11am — if aligned, mandate for this sprint scope (not another deck).</a:t>
+              <a:t>Guru redirect: 2–3 month window was too slow — he wants something concrete in the **next few days**.</a:t>
             </a:r>
           </a:p>
           <a:p/>
           <a:p>
             <a:r>
-              <a:t>Window: 2–3 months on the tape-out path. SW ↔ HW: validation gates before silicon. AV · C-model / co-dev: architecture validation and HW–SW co-development cadence. Exit: SDK, SAI, mgmt plane working on silicon.</a:t>
+              <a:t>Say: draft plan / validation gates v0 (format per his steer) — not another 50-pager. North star unchanged: tape-out with SDK, SAI, mgmt on silicon.</a:t>
             </a:r>
           </a:p>
           <a:p/>
           <a:p>
             <a:r>
-              <a:t>Gururaj touch-in at gates; I drive day-to-day technical work. Depth follows redirect after mandate.</a:t>
+              <a:t>Gururaj touch-in at gates; I drive day-to-day technical work.</a:t>
             </a:r>
           </a:p>
           <a:p/>
           <a:p>
             <a:r>
-              <a:t>Slide 4: four engineering checkpoints before Fri close. Mandate = permission to drive the sprint. Pipeline plan co-evolved on B6 — alignment, not a doc handoff.</a:t>
+              <a:t>Slide 4: four engineering checkpoints before Fri close. Mandate = permission to drive the sprint. Pipeline plan co-evolved on the walk — alignment, not a doc handoff.</a:t>
             </a:r>
           </a:p>
         </p:txBody>
@@ -2538,13 +2538,13 @@
           <a:p/>
           <a:p>
             <a:r>
-              <a:t>Scope: slides 1–2 — program bar + DBM at CSB framed correctly? Lane: QoSMAP, Queue, buffer carving vs peer DRIs. B6: logical pipeline and draft validation path. OCP: I align with Rupa on datapath standards; Gururaj carries company position externally (standards body, customer-facing).</a:t>
+              <a:t>Scope: slides 1–2 — program bar + DBM at CSB framed correctly? Lane: QoSMAP, Queue, buffer carving vs peer DRIs. Pipeline walk: logical pipeline and draft validation path. OCP: I align with Rupa on datapath standards; Gururaj carries company position externally (standards body, customer-facing).</a:t>
             </a:r>
           </a:p>
           <a:p/>
           <a:p>
             <a:r>
-              <a:t>If aligned: Fri mandate for the 2–3 month sprint — AV/C-model, SDK/SAI/mgmt integration to tape-out.</a:t>
+              <a:t>If aligned: mandate to ship **draft plan in next few days** — then iterate toward tape-out (AV/C-model, SDK/SAI/mgmt).</a:t>
             </a:r>
           </a:p>
         </p:txBody>
@@ -5489,7 +5489,7 @@
                 </a:solidFill>
                 <a:latin typeface="Calibri"/>
               </a:rPr>
-              <a:t>SW done and validated before tape-out</a:t>
+              <a:t>Done and validated before tape-out</a:t>
             </a:r>
             <a:endParaRPr sz="3000" b="0" i="0" u="none" strike="noStrike" cap="none">
               <a:solidFill>
@@ -5943,7 +5943,7 @@
                 </a:solidFill>
                 <a:latin typeface="Calibri"/>
               </a:rPr>
-              <a:t>Sprint scope · Fri close</a:t>
+              <a:t>Near-term scope</a:t>
             </a:r>
             <a:endParaRPr sz="3000" b="0" i="0" u="none" strike="noStrike" cap="none">
               <a:solidFill>

</xml_diff>

<commit_message>
Polish A3 for Guru forward-safe share and capture review triage.
Drop on-wall gate/Reframe, clarify Friday meeting and buffer carve plan, and regen diagrams so the tactical deck reads stand-alone while B6 absorbs Sr.W layout backlog.

Co-authored-by: Cursor <cursoragent@cursor.com>
</commit_message>
<xml_diff>
--- a/dt100/manager-arch-vision-a3.pptx
+++ b/dt100/manager-arch-vision-a3.pptx
@@ -1810,7 +1810,7 @@
           <a:p/>
           <a:p>
             <a:r>
-              <a:t>Left = your program bar (done and validated to tape-out). Right = my DRI wedge (DBM). Close = mandate + **concrete draft in next few days** (Guru steer post-meeting).</a:t>
+              <a:t>Left = program bar (done and validated to tape-out). Right = Diwakar DRI wedge (DBM). Close = mandate + **concrete draft in next few days** (steer post-meeting).</a:t>
             </a:r>
           </a:p>
         </p:txBody>
@@ -1989,7 +1989,7 @@
           <a:p/>
           <a:p>
             <a:r>
-              <a:t>DBM (say once): ESUN-world pair to DLB — buffers/CSB layer, not ECMP/fabric. Rupa owns datapath architecture; I drive by understanding the pipe. Peer intersects: Shafi (L2/ACL), Tippanna (ECMP/AV), SDK leads, Rupa (datapath/OCP).</a:t>
+              <a:t>DBM (say once): ESUN-world pair to DLB — buffers/CSB layer, not ECMP/fabric. **Datapath Architecture** (E-level lane; implicit owner — no name, no OCP on slide). W peers: Shafi (L2/L3/Mirroring), Tippanna (ECMP/Stats), Tilak (L2), SDK leads.</a:t>
             </a:r>
           </a:p>
           <a:p/>
@@ -2007,7 +2007,7 @@
           <a:p/>
           <a:p>
             <a:r>
-              <a:t>Bottom band = my lane: QoS RM on QoSMAP, Queue, buffer carving at CSB. This is the draft scope I execute under your steer.</a:t>
+              <a:t>Bottom band = function lane (not role title): QoSMAP, Queue, buffer carving at CSB. Bounded scope under steer.</a:t>
             </a:r>
           </a:p>
           <a:p/>
@@ -2180,19 +2180,25 @@
           <a:lstStyle/>
           <a:p>
             <a:r>
-              <a:t>Walk order: three columns **left → right**, then **down** to Aligned → QoS buffer carving arch. **Read order** on-slide: numbered arrows 1 → 2 → 3 (Guru: visual learner — how to read).</a:t>
+              <a:t>Walk order: three columns **left → right**, then **down** to QoS buffer carving arch walk. **Read order** on-slide: 1 → 2.</a:t>
             </a:r>
           </a:p>
           <a:p/>
           <a:p>
             <a:r>
-              <a:t>**Aligned · Wed 1:1** — not a re-ask. Middle column = my lane (QoS buffer carve). Bottom band = **My deliverable** — compass prefetch for org framing (no N-E-W-S label on wall).</a:t>
+              <a:t>Col 1 = tape-out validation (program). Col 2 = Diwakar lane (orange). Col 3 = peer DRIs. **Bottom row** = W intersects + buffer carve plan.</a:t>
             </a:r>
           </a:p>
           <a:p/>
           <a:p>
             <a:r>
-              <a:t>Yes → QoS buffer carving arch walk. No path grayed — closed at 1:1.</a:t>
+              <a:t>**No gate diamond** — stand-alone / forward-safe (Thippanna Sr.W + Prabhu A). Alignment / reframe with sponsor — spoken at Friday meeting, not on-wall.</a:t>
+            </a:r>
+          </a:p>
+          <a:p/>
+          <a:p>
+            <a:r>
+              <a:t>*(Thippanna stacked layout → B6 backlog.)*</a:t>
             </a:r>
           </a:p>
         </p:txBody>
@@ -2353,25 +2359,25 @@
           <a:lstStyle/>
           <a:p>
             <a:r>
-              <a:t>Guru redirect: 2–3 month window was too slow — he wants something concrete in the **next few days**.</a:t>
+              <a:t>SharePoint timeline: 2–3 month window was too slow — concrete output in the **next few days** (yellow highlight on slide).</a:t>
             </a:r>
           </a:p>
           <a:p/>
           <a:p>
             <a:r>
-              <a:t>Say: draft plan / validation gates v0 (format per his steer) — not another 50-pager. North star unchanged: tape-out with SDK, SAI, mgmt on silicon.</a:t>
+              <a:t>Say: **buffer carve plan** + validation gates v0 (format per steer) — not another 50-pager. North star unchanged: tape-out with SDK, SAI, mgmt on silicon.</a:t>
             </a:r>
           </a:p>
           <a:p/>
           <a:p>
             <a:r>
-              <a:t>Gururaj touch-in at gates; I drive day-to-day technical work.</a:t>
+              <a:t>Sponsor touch-in at gates; Diwakar drives day-to-day technical work.</a:t>
             </a:r>
           </a:p>
           <a:p/>
           <a:p>
             <a:r>
-              <a:t>Slide 4: four engineering checkpoints before Fri close. Mandate = permission to drive the sprint. Pipeline plan co-evolved on the walk — alignment, not a doc handoff.</a:t>
+              <a:t>Slide 4: four engineering checkpoints before Friday meeting close. Mandate = permission to drive the sprint. Pipeline plan co-evolved on the walk — alignment, not a doc handoff.</a:t>
             </a:r>
           </a:p>
         </p:txBody>
@@ -2538,13 +2544,13 @@
           <a:p/>
           <a:p>
             <a:r>
-              <a:t>Scope: slides 1–2 — program bar + DBM at CSB framed correctly? Lane: QoSMAP, Queue, buffer carving vs peer DRIs. Pipeline walk: logical pipeline and draft validation path. OCP: I align with Rupa on datapath standards; Gururaj carries company position externally (standards body, customer-facing).</a:t>
+              <a:t>Scope: slides 1–2 — program bar + DBM at CSB framed correctly? Lane: QoSMAP, Queue, buffer carving vs peer DRIs. Pipeline walk: logical pipeline and draft validation path. **Datapath Architecture** checkpoint — her lane; OCP implicit, not on slide.</a:t>
             </a:r>
           </a:p>
           <a:p/>
           <a:p>
             <a:r>
-              <a:t>If aligned: mandate to ship **draft plan in next few days** — then iterate toward tape-out (AV/C-model, SDK/SAI/mgmt).</a:t>
+              <a:t>If aligned: mandate to ship **buffer carve plan in next few days** → iterate toward tape-out (AV/C-model, SDK/SAI/mgmt).</a:t>
             </a:r>
           </a:p>
         </p:txBody>
@@ -3590,7 +3596,7 @@
                 <a:cs typeface="Arial"/>
                 <a:sym typeface="Arial"/>
               </a:rPr>
-              <a:t>Architecture Vision</a:t>
+              <a:t>qos architecture</a:t>
             </a:r>
             <a:endParaRPr sz="1950" b="0" i="1" u="none" strike="noStrike" cap="none">
               <a:solidFill>
@@ -3689,14 +3695,14 @@
             <a:r>
               <a:rPr lang="en-US" sz="1100" b="0" i="1" u="none" strike="noStrike" cap="none">
                 <a:solidFill>
-                  <a:srgbClr val="AABBCC"/>
+                  <a:srgbClr val="EF6C00"/>
                 </a:solidFill>
                 <a:latin typeface="Calibri"/>
                 <a:ea typeface="Calibri"/>
                 <a:cs typeface="Calibri"/>
                 <a:sym typeface="Calibri"/>
               </a:rPr>
-              <a:t>End-to-end datapath hardware–software validation</a:t>
+              <a:t>Diwakar Tundlam - qos architect</a:t>
             </a:r>
             <a:endParaRPr sz="1100" b="0" i="0" u="none" strike="noStrike" cap="none">
               <a:solidFill>
@@ -5489,7 +5495,7 @@
                 </a:solidFill>
                 <a:latin typeface="Calibri"/>
               </a:rPr>
-              <a:t>Done and validated before tape-out</a:t>
+              <a:t>Validated to tape-out</a:t>
             </a:r>
             <a:endParaRPr sz="3000" b="0" i="0" u="none" strike="noStrike" cap="none">
               <a:solidFill>
@@ -6397,7 +6403,7 @@
                 </a:solidFill>
                 <a:latin typeface="Calibri"/>
               </a:rPr>
-              <a:t>Alignment · Fri close</a:t>
+              <a:t>Alignment · Friday meeting</a:t>
             </a:r>
             <a:endParaRPr sz="3000" b="0" i="0" u="none" strike="noStrike" cap="none">
               <a:solidFill>

</xml_diff>